<commit_message>
deck_dyson: edit + baseline copies synced to the current build
Co-Authored-By: Claude Fable 5.1 <noreply@anthropic.com>
</commit_message>
<xml_diff>
--- a/demo_session/deck_dyson_baseline.pptx
+++ b/demo_session/deck_dyson_baseline.pptx
@@ -30,7 +30,6 @@
     <p:sldId id="278" r:id="rId29"/>
     <p:sldId id="279" r:id="rId30"/>
     <p:sldId id="280" r:id="rId31"/>
-    <p:sldId id="281" r:id="rId32"/>
   </p:sldIdLst>
   <p:sldSz cx="12191695" cy="6858000" type="screen4x3"/>
   <p:notesSz cx="6858000" cy="9144000"/>
@@ -5650,7 +5649,23 @@
                 </a:solidFill>
                 <a:latin typeface="Arial"/>
               </a:rPr>
-              <a:t>•  The prescription: challenges/dyson5/dyson5_s3_r4.in, eleven elements: the block's flat face, its spherical face, the meniscus (two surfaces), the grating, and the return through the meniscus and block to the focal plane; the element table is on the next slide.</a:t>
+              <a:t>•  Eleven surfaces: the block's flat and spherical faces, the meniscus, the grating, and the same faces again on the way back to the focal plane; the element table is on the next slide.</a:t>
+            </a:r>
+          </a:p>
+          <a:p>
+            <a:pPr>
+              <a:spcAft>
+                <a:spcPts val="600"/>
+              </a:spcAft>
+            </a:pPr>
+            <a:r>
+              <a:rPr sz="1500" b="0">
+                <a:solidFill>
+                  <a:srgbClr val="282828"/>
+                </a:solidFill>
+                <a:latin typeface="Arial"/>
+              </a:rPr>
+              <a:t>•  Clearance: the returning beam passes the detector carrier by 1.19 mm with no cold shield; any shield fails the check, so a fold prism at the slit is the next layout step.</a:t>
             </a:r>
           </a:p>
         </p:txBody>
@@ -5671,8 +5686,8 @@
         </p:blipFill>
         <p:spPr>
           <a:xfrm>
-            <a:off x="2903155" y="2218182"/>
-            <a:ext cx="6385383" cy="4246118"/>
+            <a:off x="3194789" y="2606039"/>
+            <a:ext cx="5802116" cy="3858260"/>
           </a:xfrm>
           <a:prstGeom prst="rect">
             <a:avLst/>
@@ -5714,45 +5729,6 @@
                 <a:latin typeface="Arial"/>
               </a:rPr>
               <a:t>3-D view and the dispersion plane (Y-Z), metres, global frame.</a:t>
-            </a:r>
-          </a:p>
-        </p:txBody>
-      </p:sp>
-      <p:sp>
-        <p:nvSpPr>
-          <p:cNvPr id="7" name="TextBox 6"/>
-          <p:cNvSpPr txBox="1"/>
-          <p:nvPr/>
-        </p:nvSpPr>
-        <p:spPr>
-          <a:xfrm>
-            <a:off x="411480" y="6748272"/>
-            <a:ext cx="11368735" cy="274320"/>
-          </a:xfrm>
-          <a:prstGeom prst="rect">
-            <a:avLst/>
-          </a:prstGeom>
-          <a:noFill/>
-        </p:spPr>
-        <p:txBody>
-          <a:bodyPr wrap="square">
-            <a:spAutoFit/>
-          </a:bodyPr>
-          <a:lstStyle/>
-          <a:p>
-            <a:pPr>
-              <a:spcAft>
-                <a:spcPts val="600"/>
-              </a:spcAft>
-            </a:pPr>
-            <a:r>
-              <a:rPr sz="1500" b="0">
-                <a:solidFill>
-                  <a:srgbClr val="282828"/>
-                </a:solidFill>
-                <a:latin typeface="Arial"/>
-              </a:rPr>
-              <a:t>•  Clearance: the worst pair is the returning beam against the detector carrier, +1.19 mm with no cold shield; any shield height fails the check, so a fold prism at the slit is the next layout step.</a:t>
             </a:r>
           </a:p>
         </p:txBody>
@@ -9400,7 +9376,7 @@
                 </a:solidFill>
                 <a:latin typeface="Arial"/>
               </a:rPr>
-              <a:t>•  8 The exact chain and the engine agree</a:t>
+              <a:t>•  8 Two independent ray traces agree</a:t>
             </a:r>
           </a:p>
           <a:p>
@@ -9890,7 +9866,7 @@
                 </a:solidFill>
                 <a:latin typeface="Arial"/>
               </a:rPr>
-              <a:t>•  Future work, once the design of record is stable: a surface-by-surface tour of the prescription (role, ray footprint, clearance, and the field where a propagation leg ends, per surface); spot diagrams in the Mouroulis &amp; Green form, slit positions down and wavelengths across inside the 18 µm pixel box; the telescope and the end-to-end instrument.</a:t>
+              <a:t>•  Future work, once the design of record is stable: a surface-by-surface tour of the prescription (role, ray footprint, clearance, and the field where a propagation leg ends, per surface); spot diagrams in the Mouroulis &amp; Green form, slit positions down and wavelengths across inside the 18 µm pixel box; the telescope and the end-to-end instrument; polarization sensitivity of the Dyson against the Offner, since the Dyson's near-normal incidence is what the literature credits for its low sensitivity.</a:t>
             </a:r>
           </a:p>
         </p:txBody>
@@ -11925,288 +11901,6 @@
 </file>
 
 <file path=ppt/slides/slide25.xml><?xml version="1.0" encoding="utf-8"?>
-<p:sld xmlns:a="http://schemas.openxmlformats.org/drawingml/2006/main" xmlns:p="http://schemas.openxmlformats.org/presentationml/2006/main" xmlns:r="http://schemas.openxmlformats.org/officeDocument/2006/relationships">
-  <p:cSld>
-    <p:spTree>
-      <p:nvGrpSpPr>
-        <p:cNvPr id="1" name=""/>
-        <p:cNvGrpSpPr/>
-        <p:nvPr/>
-      </p:nvGrpSpPr>
-      <p:grpSpPr/>
-      <p:sp>
-        <p:nvSpPr>
-          <p:cNvPr id="2" name="TextBox 1"/>
-          <p:cNvSpPr txBox="1"/>
-          <p:nvPr/>
-        </p:nvSpPr>
-        <p:spPr>
-          <a:xfrm>
-            <a:off x="411480" y="201168"/>
-            <a:ext cx="11368735" cy="914400"/>
-          </a:xfrm>
-          <a:prstGeom prst="rect">
-            <a:avLst/>
-          </a:prstGeom>
-          <a:noFill/>
-        </p:spPr>
-        <p:txBody>
-          <a:bodyPr wrap="square">
-            <a:spAutoFit/>
-          </a:bodyPr>
-          <a:lstStyle/>
-          <a:p>
-            <a:pPr>
-              <a:spcAft>
-                <a:spcPts val="400"/>
-              </a:spcAft>
-            </a:pPr>
-            <a:r>
-              <a:rPr sz="2400" b="1">
-                <a:solidFill>
-                  <a:srgbClr val="1F4E79"/>
-                </a:solidFill>
-                <a:latin typeface="Arial"/>
-              </a:rPr>
-              <a:t>Backup: the centroid question, settled</a:t>
-            </a:r>
-          </a:p>
-          <a:p>
-            <a:pPr>
-              <a:spcAft>
-                <a:spcPts val="0"/>
-              </a:spcAft>
-            </a:pPr>
-            <a:r>
-              <a:rPr sz="1250" b="0">
-                <a:solidFill>
-                  <a:srgbClr val="6E6E6E"/>
-                </a:solidFill>
-                <a:latin typeface="Arial"/>
-              </a:rPr>
-              <a:t>A 0.12 px wave-versus-ray difference on R4 was the twin's grid read in the wrong frame; the detector sees the ray centroid</a:t>
-            </a:r>
-          </a:p>
-        </p:txBody>
-      </p:sp>
-      <p:sp>
-        <p:nvSpPr>
-          <p:cNvPr id="3" name="Rectangle 2"/>
-          <p:cNvSpPr/>
-          <p:nvPr/>
-        </p:nvSpPr>
-        <p:spPr>
-          <a:xfrm>
-            <a:off x="411480" y="1133856"/>
-            <a:ext cx="11368735" cy="20320"/>
-          </a:xfrm>
-          <a:prstGeom prst="rect">
-            <a:avLst/>
-          </a:prstGeom>
-          <a:solidFill>
-            <a:srgbClr val="B8C6D4"/>
-          </a:solidFill>
-          <a:ln>
-            <a:noFill/>
-          </a:ln>
-          <a:effectLst/>
-        </p:spPr>
-        <p:style>
-          <a:lnRef idx="1">
-            <a:schemeClr val="accent1"/>
-          </a:lnRef>
-          <a:fillRef idx="3">
-            <a:schemeClr val="accent1"/>
-          </a:fillRef>
-          <a:effectRef idx="2">
-            <a:schemeClr val="accent1"/>
-          </a:effectRef>
-          <a:fontRef idx="minor">
-            <a:schemeClr val="lt1"/>
-          </a:fontRef>
-        </p:style>
-        <p:txBody>
-          <a:bodyPr rtlCol="0" anchor="ctr"/>
-          <a:lstStyle/>
-          <a:p>
-            <a:pPr algn="ctr"/>
-          </a:p>
-        </p:txBody>
-      </p:sp>
-      <p:sp>
-        <p:nvSpPr>
-          <p:cNvPr id="4" name="TextBox 3"/>
-          <p:cNvSpPr txBox="1"/>
-          <p:nvPr/>
-        </p:nvSpPr>
-        <p:spPr>
-          <a:xfrm>
-            <a:off x="411480" y="1298448"/>
-            <a:ext cx="5806440" cy="274320"/>
-          </a:xfrm>
-          <a:prstGeom prst="rect">
-            <a:avLst/>
-          </a:prstGeom>
-          <a:noFill/>
-        </p:spPr>
-        <p:txBody>
-          <a:bodyPr wrap="square">
-            <a:spAutoFit/>
-          </a:bodyPr>
-          <a:lstStyle/>
-          <a:p>
-            <a:pPr>
-              <a:spcAft>
-                <a:spcPts val="600"/>
-              </a:spcAft>
-            </a:pPr>
-            <a:r>
-              <a:rPr sz="1200" b="0">
-                <a:solidFill>
-                  <a:srgbClr val="282828"/>
-                </a:solidFill>
-                <a:latin typeface="Arial"/>
-              </a:rPr>
-              <a:t>•  The symptom: the propagated point-spread function's centroid parted from the ray centroid by 0.001 px on the seeds, 0.03 px on R3 and 0.12 px on R4, growing with wavelength, while the path-length check passed.</a:t>
-            </a:r>
-          </a:p>
-          <a:p>
-            <a:pPr>
-              <a:spcAft>
-                <a:spcPts val="600"/>
-              </a:spcAft>
-            </a:pPr>
-            <a:r>
-              <a:rPr sz="1200" b="0">
-                <a:solidFill>
-                  <a:srgbClr val="282828"/>
-                </a:solidFill>
-                <a:latin typeface="Arial"/>
-              </a:rPr>
-              <a:t>•  The proposed mechanism, tested and refuted: an amplitude-weighted ray centroid (Fresnel transmission across the pupil) reproduces the ray centroid to 4 % of the offset (0.0505 vs 0.0524 px at 2500 nm).</a:t>
-            </a:r>
-          </a:p>
-          <a:p>
-            <a:pPr>
-              <a:spcAft>
-                <a:spcPts val="600"/>
-              </a:spcAft>
-            </a:pPr>
-            <a:r>
-              <a:rPr sz="1200" b="0">
-                <a:solidFill>
-                  <a:srgbClr val="282828"/>
-                </a:solidFill>
-                <a:latin typeface="Arial"/>
-              </a:rPr>
-              <a:t>•  Numerics ruled out: doubling the window and halving the sampling reproduce every digit.</a:t>
-            </a:r>
-          </a:p>
-        </p:txBody>
-      </p:sp>
-      <p:sp>
-        <p:nvSpPr>
-          <p:cNvPr id="5" name="TextBox 4"/>
-          <p:cNvSpPr txBox="1"/>
-          <p:nvPr/>
-        </p:nvSpPr>
-        <p:spPr>
-          <a:xfrm>
-            <a:off x="6400800" y="1298448"/>
-            <a:ext cx="5394960" cy="274320"/>
-          </a:xfrm>
-          <a:prstGeom prst="rect">
-            <a:avLst/>
-          </a:prstGeom>
-          <a:noFill/>
-        </p:spPr>
-        <p:txBody>
-          <a:bodyPr wrap="square">
-            <a:spAutoFit/>
-          </a:bodyPr>
-          <a:lstStyle/>
-          <a:p>
-            <a:pPr>
-              <a:spcAft>
-                <a:spcPts val="600"/>
-              </a:spcAft>
-            </a:pPr>
-            <a:r>
-              <a:rPr sz="1200" b="0">
-                <a:solidFill>
-                  <a:srgbClr val="282828"/>
-                </a:solidFill>
-                <a:latin typeface="Arial"/>
-              </a:rPr>
-              <a:t>•  The cause: the far-field grid carries the source grid's orientation in index space, inverted by the transform; the prescription's y axis is chief × x, which is +y on the Dyson's chief and −y on the Offner's.  Raw centroids on R4 were the ray offsets with both signs flipped, on the Offner with one.</a:t>
-            </a:r>
-          </a:p>
-          <a:p>
-            <a:pPr>
-              <a:spcAft>
-                <a:spcPts val="600"/>
-              </a:spcAft>
-            </a:pPr>
-            <a:r>
-              <a:rPr sz="1200" b="0">
-                <a:solidFill>
-                  <a:srgbClr val="282828"/>
-                </a:solidFill>
-                <a:latin typeface="Arial"/>
-              </a:rPr>
-              <a:t>•  The fix: the harness takes the signs from the engine's source frame and states them in its record.  After it: agreement 0.0022 px (R4) and 0.0058 px (Offner) at every slit position and wavelength.  The concentric seed could never have shown this; it had no offset to flip.</a:t>
-            </a:r>
-          </a:p>
-        </p:txBody>
-      </p:sp>
-      <p:sp>
-        <p:nvSpPr>
-          <p:cNvPr id="6" name="TextBox 5"/>
-          <p:cNvSpPr txBox="1"/>
-          <p:nvPr/>
-        </p:nvSpPr>
-        <p:spPr>
-          <a:xfrm>
-            <a:off x="6400800" y="3398519"/>
-            <a:ext cx="5394960" cy="274320"/>
-          </a:xfrm>
-          <a:prstGeom prst="rect">
-            <a:avLst/>
-          </a:prstGeom>
-          <a:noFill/>
-        </p:spPr>
-        <p:txBody>
-          <a:bodyPr wrap="square">
-            <a:spAutoFit/>
-          </a:bodyPr>
-          <a:lstStyle/>
-          <a:p>
-            <a:pPr>
-              <a:spcAft>
-                <a:spcPts val="600"/>
-              </a:spcAft>
-            </a:pPr>
-            <a:r>
-              <a:rPr sz="1050" b="0">
-                <a:solidFill>
-                  <a:srgbClr val="6E6E6E"/>
-                </a:solidFill>
-                <a:latin typeface="Arial"/>
-              </a:rPr>
-              <a:t>Record: dyson5_s2w.txt, dyson5_s2w_R3control.txt; convention in the reference document.</a:t>
-            </a:r>
-          </a:p>
-        </p:txBody>
-      </p:sp>
-    </p:spTree>
-  </p:cSld>
-  <p:clrMapOvr>
-    <a:masterClrMapping/>
-  </p:clrMapOvr>
-</p:sld>
-</file>
-
-<file path=ppt/slides/slide26.xml><?xml version="1.0" encoding="utf-8"?>
 <p:sld xmlns:a="http://schemas.openxmlformats.org/drawingml/2006/main" xmlns:p="http://schemas.openxmlformats.org/presentationml/2006/main" xmlns:r="http://schemas.openxmlformats.org/officeDocument/2006/relationships">
   <p:cSld>
     <p:spTree>
@@ -16820,7 +16514,7 @@
                 </a:solidFill>
                 <a:latin typeface="Arial"/>
               </a:rPr>
-              <a:t>The exact chain and the engine agree</a:t>
+              <a:t>Two independent ray traces agree</a:t>
             </a:r>
           </a:p>
           <a:p>
@@ -16836,7 +16530,7 @@
                 </a:solidFill>
                 <a:latin typeface="Arial"/>
               </a:rPr>
-              <a:t>Every engine ray re-traced by the chain from the engine's own launch directions lands within 1e-9 m</a:t>
+              <a:t>The design solver and MACOS place every ray within a nanometre of each other, so the prescription is what the solver intended</a:t>
             </a:r>
           </a:p>
         </p:txBody>
@@ -16919,7 +16613,7 @@
                 </a:solidFill>
                 <a:latin typeface="Arial"/>
               </a:rPr>
-              <a:t>•  The check: the engine's chief ray and every ray of its grid are re-traced through the chain's surfaces from the engine's launch directions; agreement is per ray, every surface, 1e-9 m; the dispersed band spans the focal plane to 1 %.</a:t>
+              <a:t>•  Two programs, one prescription. The design solver (MATLAB) lays out each form from its design rules and writes the prescription.  MACOS then traces that prescription on its own.  The check: every ray MACOS launches is re-traced by the solver through the same surfaces, and the two land within 1e-9 m at every surface; the dispersed band spans the detector to 1 %.</a:t>
             </a:r>
           </a:p>
           <a:p>
@@ -16935,7 +16629,7 @@
                 </a:solidFill>
                 <a:latin typeface="Arial"/>
               </a:rPr>
-              <a:t>•  With the aspheric block face (ladder step R2): agreement 1e-12 m per ray; a sphere-only chain misses by 0.26 mm, so the check is not vacuous.</a:t>
+              <a:t>•  The check is not trivial. With the aspheric block face of ladder step R2 the agreement is 1e-12 m per ray, while a solver that ignores the asphere misses by 0.26 mm.</a:t>
             </a:r>
           </a:p>
           <a:p>
@@ -16951,7 +16645,7 @@
                 </a:solidFill>
                 <a:latin typeface="Arial"/>
               </a:rPr>
-              <a:t>•  The physical-optics twin: a far-field terminal on a reference sphere upstream of the focal plane, re-posed per slit position and wavelength; on the Offner at order 0 the pupil OPD is 8e-11 m and the Airy spot puts 94 % of its energy in one 18 µm pixel.</a:t>
+              <a:t>•  Wave propagation agrees too. On the Offner at order 0 the propagated point image is a clean Airy pattern, 85 % of its energy in one pixel, with a pupil error of 8e-11 m.</a:t>
             </a:r>
           </a:p>
         </p:txBody>
@@ -16990,7 +16684,7 @@
                 </a:solidFill>
                 <a:latin typeface="Arial"/>
               </a:rPr>
-              <a:t>•  What the checks found in the engine, now fixed (details in Backup): glass names were ignored at load; propagation inside glass used the vacuum wavelength; the grating groove period was held constant along the curved surface instead of along the chord; the grating's path-length jump had the matching defect.  Each has a regression test written from the physics, not from the engine.</a:t>
+              <a:t>•  What the checks found in MACOS, and fixed (details in Backup): glass names were ignored when a prescription loaded; propagation inside glass used the vacuum wavelength; a grating's groove spacing was held constant along the curved surface instead of along the chord; the grating's path-length term had the matching defect.  Each now has a regression test written from the physics.</a:t>
             </a:r>
           </a:p>
         </p:txBody>
@@ -17029,7 +16723,7 @@
                 </a:solidFill>
                 <a:latin typeface="Arial"/>
               </a:rPr>
-              <a:t>Regression tests: tSpectrometerRx (3), tGratingOpl (2), tGratingImmersed (4), tGlassDispersion (3), tPropMedium (3); mmacos fast suite 501 pass, 0 fail (2026-10-01).</a:t>
+              <a:t>Regression tests: 15 in five classes; the MACOS fast suite stands at 504 pass, 0 fail (2026-10-01).</a:t>
             </a:r>
           </a:p>
         </p:txBody>

</xml_diff>